<commit_message>
Add 이해도 확인 질문·정답 to Main Quest deck (main-quest)
회고로만 닫혀 있던 것을 다른 덱과 일관되게 — 질문 5 + 정답·해설 슬라이드 추가
(회고와 마무리 사이). 31→33 슬라이드. 앞쪽 슬라이드 번호 불변이라 홈 #해시 링크 유효.

Co-Authored-By: Claude Opus 4.8 <noreply@anthropic.com>
</commit_message>
<xml_diff>
--- a/main-quest/main-quest.pptx
+++ b/main-quest/main-quest.pptx
@@ -36,9 +36,11 @@
     <p:sldId id="284" r:id="rId30"/>
     <p:sldId id="285" r:id="rId31"/>
     <p:sldId id="286" r:id="rId32"/>
+    <p:sldId id="287" r:id="rId33"/>
+    <p:sldId id="288" r:id="rId34"/>
   </p:sldIdLst>
   <p:notesMasterIdLst>
-    <p:notesMasterId r:id="rId33"/>
+    <p:notesMasterId r:id="rId35"/>
   </p:notesMasterIdLst>
   <p:sldSz cx="12192000" cy="6858000"/>
   <p:notesSz cx="6858000" cy="12192000"/>
@@ -2668,6 +2670,182 @@
             <a:fld id="{F7021451-1387-4CA6-816F-3879F97B5CBC}" type="slidenum">
               <a:rPr lang="en-US"/>
               <a:t>31</a:t>
+            </a:fld>
+            <a:endParaRPr lang="en-US"/>
+          </a:p>
+        </p:txBody>
+      </p:sp>
+    </p:spTree>
+    <p:extLst>
+      <p:ext uri="{BB962C8B-B14F-4D97-AF65-F5344CB8AC3E}">
+        <p14:creationId xmlns:p14="http://schemas.microsoft.com/office/powerpoint/2010/main" val="1024086991"/>
+      </p:ext>
+    </p:extLst>
+  </p:cSld>
+  <p:clrMapOvr>
+    <a:masterClrMapping/>
+  </p:clrMapOvr>
+</p:notes>
+</file>
+
+<file path=ppt/notesSlides/notesSlide32.xml><?xml version="1.0" encoding="utf-8"?>
+<p:notes xmlns:a="http://schemas.openxmlformats.org/drawingml/2006/main" xmlns:r="http://schemas.openxmlformats.org/officeDocument/2006/relationships" xmlns:p="http://schemas.openxmlformats.org/presentationml/2006/main">
+  <p:cSld>
+    <p:spTree>
+      <p:nvGrpSpPr>
+        <p:cNvPr id="1" name=""/>
+        <p:cNvGrpSpPr/>
+        <p:nvPr/>
+      </p:nvGrpSpPr>
+      <p:grpSpPr>
+        <a:xfrm>
+          <a:off x="0" y="0"/>
+          <a:ext cx="0" cy="0"/>
+          <a:chOff x="0" y="0"/>
+          <a:chExt cx="0" cy="0"/>
+        </a:xfrm>
+      </p:grpSpPr>
+      <p:sp>
+        <p:nvSpPr>
+          <p:cNvPr id="2" name="Slide Image Placeholder 1"/>
+          <p:cNvSpPr>
+            <a:spLocks noGrp="1" noRot="1" noChangeAspect="1"/>
+          </p:cNvSpPr>
+          <p:nvPr>
+            <p:ph type="sldImg"/>
+          </p:nvPr>
+        </p:nvSpPr>
+        <p:spPr/>
+      </p:sp>
+      <p:sp>
+        <p:nvSpPr>
+          <p:cNvPr id="3" name="Notes Placeholder 2"/>
+          <p:cNvSpPr>
+            <a:spLocks noGrp="1"/>
+          </p:cNvSpPr>
+          <p:nvPr>
+            <p:ph type="body" idx="1"/>
+          </p:nvPr>
+        </p:nvSpPr>
+        <p:spPr/>
+        <p:txBody>
+          <a:bodyPr/>
+          <a:lstStyle/>
+          <a:p>
+            <a:r>
+              <a:rPr lang="en-US" dirty="0"/>
+              <a:t/>
+            </a:r>
+            <a:endParaRPr lang="en-US" dirty="0"/>
+          </a:p>
+        </p:txBody>
+      </p:sp>
+      <p:sp>
+        <p:nvSpPr>
+          <p:cNvPr id="4" name="Slide Number Placeholder 3"/>
+          <p:cNvSpPr>
+            <a:spLocks noGrp="1"/>
+          </p:cNvSpPr>
+          <p:nvPr>
+            <p:ph type="sldNum" sz="quarter" idx="10"/>
+          </p:nvPr>
+        </p:nvSpPr>
+        <p:spPr/>
+        <p:txBody>
+          <a:bodyPr/>
+          <a:lstStyle/>
+          <a:p>
+            <a:fld id="{F7021451-1387-4CA6-816F-3879F97B5CBC}" type="slidenum">
+              <a:rPr lang="en-US"/>
+              <a:t>32</a:t>
+            </a:fld>
+            <a:endParaRPr lang="en-US"/>
+          </a:p>
+        </p:txBody>
+      </p:sp>
+    </p:spTree>
+    <p:extLst>
+      <p:ext uri="{BB962C8B-B14F-4D97-AF65-F5344CB8AC3E}">
+        <p14:creationId xmlns:p14="http://schemas.microsoft.com/office/powerpoint/2010/main" val="1024086991"/>
+      </p:ext>
+    </p:extLst>
+  </p:cSld>
+  <p:clrMapOvr>
+    <a:masterClrMapping/>
+  </p:clrMapOvr>
+</p:notes>
+</file>
+
+<file path=ppt/notesSlides/notesSlide33.xml><?xml version="1.0" encoding="utf-8"?>
+<p:notes xmlns:a="http://schemas.openxmlformats.org/drawingml/2006/main" xmlns:r="http://schemas.openxmlformats.org/officeDocument/2006/relationships" xmlns:p="http://schemas.openxmlformats.org/presentationml/2006/main">
+  <p:cSld>
+    <p:spTree>
+      <p:nvGrpSpPr>
+        <p:cNvPr id="1" name=""/>
+        <p:cNvGrpSpPr/>
+        <p:nvPr/>
+      </p:nvGrpSpPr>
+      <p:grpSpPr>
+        <a:xfrm>
+          <a:off x="0" y="0"/>
+          <a:ext cx="0" cy="0"/>
+          <a:chOff x="0" y="0"/>
+          <a:chExt cx="0" cy="0"/>
+        </a:xfrm>
+      </p:grpSpPr>
+      <p:sp>
+        <p:nvSpPr>
+          <p:cNvPr id="2" name="Slide Image Placeholder 1"/>
+          <p:cNvSpPr>
+            <a:spLocks noGrp="1" noRot="1" noChangeAspect="1"/>
+          </p:cNvSpPr>
+          <p:nvPr>
+            <p:ph type="sldImg"/>
+          </p:nvPr>
+        </p:nvSpPr>
+        <p:spPr/>
+      </p:sp>
+      <p:sp>
+        <p:nvSpPr>
+          <p:cNvPr id="3" name="Notes Placeholder 2"/>
+          <p:cNvSpPr>
+            <a:spLocks noGrp="1"/>
+          </p:cNvSpPr>
+          <p:nvPr>
+            <p:ph type="body" idx="1"/>
+          </p:nvPr>
+        </p:nvSpPr>
+        <p:spPr/>
+        <p:txBody>
+          <a:bodyPr/>
+          <a:lstStyle/>
+          <a:p>
+            <a:r>
+              <a:rPr lang="en-US" dirty="0"/>
+              <a:t/>
+            </a:r>
+            <a:endParaRPr lang="en-US" dirty="0"/>
+          </a:p>
+        </p:txBody>
+      </p:sp>
+      <p:sp>
+        <p:nvSpPr>
+          <p:cNvPr id="4" name="Slide Number Placeholder 3"/>
+          <p:cNvSpPr>
+            <a:spLocks noGrp="1"/>
+          </p:cNvSpPr>
+          <p:nvPr>
+            <p:ph type="sldNum" sz="quarter" idx="10"/>
+          </p:nvPr>
+        </p:nvSpPr>
+        <p:spPr/>
+        <p:txBody>
+          <a:bodyPr/>
+          <a:lstStyle/>
+          <a:p>
+            <a:fld id="{F7021451-1387-4CA6-816F-3879F97B5CBC}" type="slidenum">
+              <a:rPr lang="en-US"/>
+              <a:t>33</a:t>
             </a:fld>
             <a:endParaRPr lang="en-US"/>
           </a:p>
@@ -21867,6 +22045,1935 @@
     <p:bg>
       <p:bgPr>
         <a:solidFill>
+          <a:srgbClr val="FAF8F4"/>
+        </a:solidFill>
+      </p:bgPr>
+    </p:bg>
+    <p:spTree>
+      <p:nvGrpSpPr>
+        <p:cNvPr id="1" name=""/>
+        <p:cNvGrpSpPr/>
+        <p:nvPr/>
+      </p:nvGrpSpPr>
+      <p:grpSpPr>
+        <a:xfrm>
+          <a:off x="0" y="0"/>
+          <a:ext cx="0" cy="0"/>
+          <a:chOff x="0" y="0"/>
+          <a:chExt cx="0" cy="0"/>
+        </a:xfrm>
+      </p:grpSpPr>
+      <p:sp>
+        <p:nvSpPr>
+          <p:cNvPr id="2" name="Text 0"/>
+          <p:cNvSpPr/>
+          <p:nvPr/>
+        </p:nvSpPr>
+        <p:spPr>
+          <a:xfrm>
+            <a:off x="548640" y="384048"/>
+            <a:ext cx="11091672" cy="731520"/>
+          </a:xfrm>
+          <a:prstGeom prst="rect">
+            <a:avLst/>
+          </a:prstGeom>
+          <a:noFill/>
+          <a:ln/>
+        </p:spPr>
+        <p:txBody>
+          <a:bodyPr wrap="square" rtlCol="0" anchor="ctr">
+            <a:normAutofit/>
+          </a:bodyPr>
+          <a:lstStyle/>
+          <a:p>
+            <a:pPr indent="0" marL="0">
+              <a:buNone/>
+            </a:pPr>
+            <a:r>
+              <a:rPr lang="en-US" sz="2400" b="1" dirty="0">
+                <a:solidFill>
+                  <a:srgbClr val="2A2723"/>
+                </a:solidFill>
+                <a:latin typeface="Malgun Gothic" pitchFamily="34" charset="0"/>
+                <a:ea typeface="Malgun Gothic" pitchFamily="34" charset="-122"/>
+                <a:cs typeface="Malgun Gothic" pitchFamily="34" charset="-120"/>
+              </a:rPr>
+              <a:t>🎯 이해도 확인 질문</a:t>
+            </a:r>
+            <a:endParaRPr lang="en-US" sz="2400" dirty="0"/>
+          </a:p>
+        </p:txBody>
+      </p:sp>
+      <p:sp>
+        <p:nvSpPr>
+          <p:cNvPr id="3" name="Shape 1"/>
+          <p:cNvSpPr/>
+          <p:nvPr/>
+        </p:nvSpPr>
+        <p:spPr>
+          <a:xfrm>
+            <a:off x="566928" y="1133856"/>
+            <a:ext cx="777240" cy="41148"/>
+          </a:xfrm>
+          <a:prstGeom prst="rect">
+            <a:avLst/>
+          </a:prstGeom>
+          <a:solidFill>
+            <a:srgbClr val="3F6B5F"/>
+          </a:solidFill>
+          <a:ln/>
+        </p:spPr>
+      </p:sp>
+      <p:sp>
+        <p:nvSpPr>
+          <p:cNvPr id="4" name="Shape 2"/>
+          <p:cNvSpPr/>
+          <p:nvPr/>
+        </p:nvSpPr>
+        <p:spPr>
+          <a:xfrm>
+            <a:off x="612648" y="1371600"/>
+            <a:ext cx="11027664" cy="437464"/>
+          </a:xfrm>
+          <a:prstGeom prst="roundRect">
+            <a:avLst>
+              <a:gd name="adj" fmla="val 18812"/>
+            </a:avLst>
+          </a:prstGeom>
+          <a:solidFill>
+            <a:srgbClr val="FFFFFF"/>
+          </a:solidFill>
+          <a:ln w="12700">
+            <a:solidFill>
+              <a:srgbClr val="E3DACB"/>
+            </a:solidFill>
+            <a:prstDash val="solid"/>
+          </a:ln>
+        </p:spPr>
+      </p:sp>
+      <p:sp>
+        <p:nvSpPr>
+          <p:cNvPr id="5" name="Shape 3"/>
+          <p:cNvSpPr/>
+          <p:nvPr/>
+        </p:nvSpPr>
+        <p:spPr>
+          <a:xfrm>
+            <a:off x="548640" y="1371600"/>
+            <a:ext cx="64008" cy="437464"/>
+          </a:xfrm>
+          <a:prstGeom prst="rect">
+            <a:avLst/>
+          </a:prstGeom>
+          <a:solidFill>
+            <a:srgbClr val="3F6B5F"/>
+          </a:solidFill>
+          <a:ln/>
+        </p:spPr>
+      </p:sp>
+      <p:sp>
+        <p:nvSpPr>
+          <p:cNvPr id="6" name="Text 4"/>
+          <p:cNvSpPr/>
+          <p:nvPr/>
+        </p:nvSpPr>
+        <p:spPr>
+          <a:xfrm>
+            <a:off x="786384" y="1371600"/>
+            <a:ext cx="10707624" cy="437464"/>
+          </a:xfrm>
+          <a:prstGeom prst="rect">
+            <a:avLst/>
+          </a:prstGeom>
+          <a:noFill/>
+          <a:ln/>
+        </p:spPr>
+        <p:txBody>
+          <a:bodyPr wrap="square" rtlCol="0" anchor="ctr">
+            <a:normAutofit/>
+          </a:bodyPr>
+          <a:lstStyle/>
+          <a:p>
+            <a:pPr indent="0" marL="0">
+              <a:lnSpc>
+                <a:spcPct val="102000"/>
+              </a:lnSpc>
+              <a:buNone/>
+            </a:pPr>
+            <a:r>
+              <a:rPr lang="en-US" sz="1250" b="1" dirty="0">
+                <a:solidFill>
+                  <a:srgbClr val="2A2723"/>
+                </a:solidFill>
+                <a:latin typeface="Malgun Gothic" pitchFamily="34" charset="0"/>
+                <a:ea typeface="Malgun Gothic" pitchFamily="34" charset="-122"/>
+                <a:cs typeface="Malgun Gothic" pitchFamily="34" charset="-120"/>
+              </a:rPr>
+              <a:t>Q1.</a:t>
+            </a:r>
+            <a:pPr indent="0" marL="0">
+              <a:lnSpc>
+                <a:spcPct val="102000"/>
+              </a:lnSpc>
+              <a:buNone/>
+            </a:pPr>
+            <a:r>
+              <a:rPr lang="en-US" sz="1250" dirty="0">
+                <a:solidFill>
+                  <a:srgbClr val="2A2723"/>
+                </a:solidFill>
+                <a:latin typeface="Malgun Gothic" pitchFamily="34" charset="0"/>
+                <a:ea typeface="Malgun Gothic" pitchFamily="34" charset="-122"/>
+                <a:cs typeface="Malgun Gothic" pitchFamily="34" charset="-120"/>
+              </a:rPr>
+              <a:t> </a:t>
+            </a:r>
+            <a:pPr indent="0" marL="0">
+              <a:lnSpc>
+                <a:spcPct val="102000"/>
+              </a:lnSpc>
+              <a:buNone/>
+            </a:pPr>
+            <a:r>
+              <a:rPr lang="en-US" sz="1250" b="1" dirty="0">
+                <a:solidFill>
+                  <a:srgbClr val="2A2723"/>
+                </a:solidFill>
+                <a:latin typeface="Malgun Gothic" pitchFamily="34" charset="0"/>
+                <a:ea typeface="Malgun Gothic" pitchFamily="34" charset="-122"/>
+                <a:cs typeface="Malgun Gothic" pitchFamily="34" charset="-120"/>
+              </a:rPr>
+              <a:t>PoC와 완성품</a:t>
+            </a:r>
+            <a:pPr indent="0" marL="0">
+              <a:lnSpc>
+                <a:spcPct val="102000"/>
+              </a:lnSpc>
+              <a:buNone/>
+            </a:pPr>
+            <a:r>
+              <a:rPr lang="en-US" sz="1250" dirty="0">
+                <a:solidFill>
+                  <a:srgbClr val="2A2723"/>
+                </a:solidFill>
+                <a:latin typeface="Malgun Gothic" pitchFamily="34" charset="0"/>
+                <a:ea typeface="Malgun Gothic" pitchFamily="34" charset="-122"/>
+                <a:cs typeface="Malgun Gothic" pitchFamily="34" charset="-120"/>
+              </a:rPr>
+              <a:t>의 목적 차이는? PoC의 산출물은 무엇인가?</a:t>
+            </a:r>
+            <a:endParaRPr lang="en-US" sz="1250" dirty="0"/>
+          </a:p>
+        </p:txBody>
+      </p:sp>
+      <p:sp>
+        <p:nvSpPr>
+          <p:cNvPr id="7" name="Shape 5"/>
+          <p:cNvSpPr/>
+          <p:nvPr/>
+        </p:nvSpPr>
+        <p:spPr>
+          <a:xfrm>
+            <a:off x="612648" y="1891360"/>
+            <a:ext cx="11027664" cy="437464"/>
+          </a:xfrm>
+          <a:prstGeom prst="roundRect">
+            <a:avLst>
+              <a:gd name="adj" fmla="val 18812"/>
+            </a:avLst>
+          </a:prstGeom>
+          <a:solidFill>
+            <a:srgbClr val="FFFFFF"/>
+          </a:solidFill>
+          <a:ln w="12700">
+            <a:solidFill>
+              <a:srgbClr val="E3DACB"/>
+            </a:solidFill>
+            <a:prstDash val="solid"/>
+          </a:ln>
+        </p:spPr>
+      </p:sp>
+      <p:sp>
+        <p:nvSpPr>
+          <p:cNvPr id="8" name="Shape 6"/>
+          <p:cNvSpPr/>
+          <p:nvPr/>
+        </p:nvSpPr>
+        <p:spPr>
+          <a:xfrm>
+            <a:off x="548640" y="1891360"/>
+            <a:ext cx="64008" cy="437464"/>
+          </a:xfrm>
+          <a:prstGeom prst="rect">
+            <a:avLst/>
+          </a:prstGeom>
+          <a:solidFill>
+            <a:srgbClr val="3F6B5F"/>
+          </a:solidFill>
+          <a:ln/>
+        </p:spPr>
+      </p:sp>
+      <p:sp>
+        <p:nvSpPr>
+          <p:cNvPr id="9" name="Text 7"/>
+          <p:cNvSpPr/>
+          <p:nvPr/>
+        </p:nvSpPr>
+        <p:spPr>
+          <a:xfrm>
+            <a:off x="786384" y="1891360"/>
+            <a:ext cx="10707624" cy="437464"/>
+          </a:xfrm>
+          <a:prstGeom prst="rect">
+            <a:avLst/>
+          </a:prstGeom>
+          <a:noFill/>
+          <a:ln/>
+        </p:spPr>
+        <p:txBody>
+          <a:bodyPr wrap="square" rtlCol="0" anchor="ctr">
+            <a:normAutofit/>
+          </a:bodyPr>
+          <a:lstStyle/>
+          <a:p>
+            <a:pPr indent="0" marL="0">
+              <a:lnSpc>
+                <a:spcPct val="102000"/>
+              </a:lnSpc>
+              <a:buNone/>
+            </a:pPr>
+            <a:r>
+              <a:rPr lang="en-US" sz="1250" b="1" dirty="0">
+                <a:solidFill>
+                  <a:srgbClr val="2A2723"/>
+                </a:solidFill>
+                <a:latin typeface="Malgun Gothic" pitchFamily="34" charset="0"/>
+                <a:ea typeface="Malgun Gothic" pitchFamily="34" charset="-122"/>
+                <a:cs typeface="Malgun Gothic" pitchFamily="34" charset="-120"/>
+              </a:rPr>
+              <a:t>Q2.</a:t>
+            </a:r>
+            <a:pPr indent="0" marL="0">
+              <a:lnSpc>
+                <a:spcPct val="102000"/>
+              </a:lnSpc>
+              <a:buNone/>
+            </a:pPr>
+            <a:r>
+              <a:rPr lang="en-US" sz="1250" dirty="0">
+                <a:solidFill>
+                  <a:srgbClr val="2A2723"/>
+                </a:solidFill>
+                <a:latin typeface="Malgun Gothic" pitchFamily="34" charset="0"/>
+                <a:ea typeface="Malgun Gothic" pitchFamily="34" charset="-122"/>
+                <a:cs typeface="Malgun Gothic" pitchFamily="34" charset="-120"/>
+              </a:rPr>
+              <a:t> 업무 </a:t>
+            </a:r>
+            <a:pPr indent="0" marL="0">
+              <a:lnSpc>
+                <a:spcPct val="102000"/>
+              </a:lnSpc>
+              <a:buNone/>
+            </a:pPr>
+            <a:r>
+              <a:rPr lang="en-US" sz="1250" b="1" dirty="0">
+                <a:solidFill>
+                  <a:srgbClr val="2A2723"/>
+                </a:solidFill>
+                <a:latin typeface="Malgun Gothic" pitchFamily="34" charset="0"/>
+                <a:ea typeface="Malgun Gothic" pitchFamily="34" charset="-122"/>
+                <a:cs typeface="Malgun Gothic" pitchFamily="34" charset="-120"/>
+              </a:rPr>
+              <a:t>네 유형</a:t>
+            </a:r>
+            <a:pPr indent="0" marL="0">
+              <a:lnSpc>
+                <a:spcPct val="102000"/>
+              </a:lnSpc>
+              <a:buNone/>
+            </a:pPr>
+            <a:r>
+              <a:rPr lang="en-US" sz="1250" dirty="0">
+                <a:solidFill>
+                  <a:srgbClr val="2A2723"/>
+                </a:solidFill>
+                <a:latin typeface="Malgun Gothic" pitchFamily="34" charset="0"/>
+                <a:ea typeface="Malgun Gothic" pitchFamily="34" charset="-122"/>
+                <a:cs typeface="Malgun Gothic" pitchFamily="34" charset="-120"/>
+              </a:rPr>
+              <a:t>과 각 병목은? </a:t>
+            </a:r>
+            <a:pPr indent="0" marL="0">
+              <a:lnSpc>
+                <a:spcPct val="102000"/>
+              </a:lnSpc>
+              <a:buNone/>
+            </a:pPr>
+            <a:r>
+              <a:rPr lang="en-US" sz="1250" b="1" dirty="0">
+                <a:solidFill>
+                  <a:srgbClr val="2A2723"/>
+                </a:solidFill>
+                <a:latin typeface="Malgun Gothic" pitchFamily="34" charset="0"/>
+                <a:ea typeface="Malgun Gothic" pitchFamily="34" charset="-122"/>
+                <a:cs typeface="Malgun Gothic" pitchFamily="34" charset="-120"/>
+              </a:rPr>
+              <a:t>검사·판독</a:t>
+            </a:r>
+            <a:pPr indent="0" marL="0">
+              <a:lnSpc>
+                <a:spcPct val="102000"/>
+              </a:lnSpc>
+              <a:buNone/>
+            </a:pPr>
+            <a:r>
+              <a:rPr lang="en-US" sz="1250" dirty="0">
+                <a:solidFill>
+                  <a:srgbClr val="2A2723"/>
+                </a:solidFill>
+                <a:latin typeface="Malgun Gothic" pitchFamily="34" charset="0"/>
+                <a:ea typeface="Malgun Gothic" pitchFamily="34" charset="-122"/>
+                <a:cs typeface="Malgun Gothic" pitchFamily="34" charset="-120"/>
+              </a:rPr>
+              <a:t>에서 도입 근거를 정확도로 잡으면 왜 안 되나?</a:t>
+            </a:r>
+            <a:endParaRPr lang="en-US" sz="1250" dirty="0"/>
+          </a:p>
+        </p:txBody>
+      </p:sp>
+      <p:sp>
+        <p:nvSpPr>
+          <p:cNvPr id="10" name="Shape 8"/>
+          <p:cNvSpPr/>
+          <p:nvPr/>
+        </p:nvSpPr>
+        <p:spPr>
+          <a:xfrm>
+            <a:off x="612648" y="2411120"/>
+            <a:ext cx="11027664" cy="437464"/>
+          </a:xfrm>
+          <a:prstGeom prst="roundRect">
+            <a:avLst>
+              <a:gd name="adj" fmla="val 18812"/>
+            </a:avLst>
+          </a:prstGeom>
+          <a:solidFill>
+            <a:srgbClr val="FFFFFF"/>
+          </a:solidFill>
+          <a:ln w="12700">
+            <a:solidFill>
+              <a:srgbClr val="E3DACB"/>
+            </a:solidFill>
+            <a:prstDash val="solid"/>
+          </a:ln>
+        </p:spPr>
+      </p:sp>
+      <p:sp>
+        <p:nvSpPr>
+          <p:cNvPr id="11" name="Shape 9"/>
+          <p:cNvSpPr/>
+          <p:nvPr/>
+        </p:nvSpPr>
+        <p:spPr>
+          <a:xfrm>
+            <a:off x="548640" y="2411120"/>
+            <a:ext cx="64008" cy="437464"/>
+          </a:xfrm>
+          <a:prstGeom prst="rect">
+            <a:avLst/>
+          </a:prstGeom>
+          <a:solidFill>
+            <a:srgbClr val="3F6B5F"/>
+          </a:solidFill>
+          <a:ln/>
+        </p:spPr>
+      </p:sp>
+      <p:sp>
+        <p:nvSpPr>
+          <p:cNvPr id="12" name="Text 10"/>
+          <p:cNvSpPr/>
+          <p:nvPr/>
+        </p:nvSpPr>
+        <p:spPr>
+          <a:xfrm>
+            <a:off x="786384" y="2411120"/>
+            <a:ext cx="10707624" cy="437464"/>
+          </a:xfrm>
+          <a:prstGeom prst="rect">
+            <a:avLst/>
+          </a:prstGeom>
+          <a:noFill/>
+          <a:ln/>
+        </p:spPr>
+        <p:txBody>
+          <a:bodyPr wrap="square" rtlCol="0" anchor="ctr">
+            <a:normAutofit/>
+          </a:bodyPr>
+          <a:lstStyle/>
+          <a:p>
+            <a:pPr indent="0" marL="0">
+              <a:lnSpc>
+                <a:spcPct val="102000"/>
+              </a:lnSpc>
+              <a:buNone/>
+            </a:pPr>
+            <a:r>
+              <a:rPr lang="en-US" sz="1250" b="1" dirty="0">
+                <a:solidFill>
+                  <a:srgbClr val="2A2723"/>
+                </a:solidFill>
+                <a:latin typeface="Malgun Gothic" pitchFamily="34" charset="0"/>
+                <a:ea typeface="Malgun Gothic" pitchFamily="34" charset="-122"/>
+                <a:cs typeface="Malgun Gothic" pitchFamily="34" charset="-120"/>
+              </a:rPr>
+              <a:t>Q3.</a:t>
+            </a:r>
+            <a:pPr indent="0" marL="0">
+              <a:lnSpc>
+                <a:spcPct val="102000"/>
+              </a:lnSpc>
+              <a:buNone/>
+            </a:pPr>
+            <a:r>
+              <a:rPr lang="en-US" sz="1250" dirty="0">
+                <a:solidFill>
+                  <a:srgbClr val="2A2723"/>
+                </a:solidFill>
+                <a:latin typeface="Malgun Gothic" pitchFamily="34" charset="0"/>
+                <a:ea typeface="Malgun Gothic" pitchFamily="34" charset="-122"/>
+                <a:cs typeface="Malgun Gothic" pitchFamily="34" charset="-120"/>
+              </a:rPr>
+              <a:t> 후보를 "크기가 아니라 </a:t>
+            </a:r>
+            <a:pPr indent="0" marL="0">
+              <a:lnSpc>
+                <a:spcPct val="102000"/>
+              </a:lnSpc>
+              <a:buNone/>
+            </a:pPr>
+            <a:r>
+              <a:rPr lang="en-US" sz="1250" b="1" dirty="0">
+                <a:solidFill>
+                  <a:srgbClr val="2A2723"/>
+                </a:solidFill>
+                <a:latin typeface="Malgun Gothic" pitchFamily="34" charset="0"/>
+                <a:ea typeface="Malgun Gothic" pitchFamily="34" charset="-122"/>
+                <a:cs typeface="Malgun Gothic" pitchFamily="34" charset="-120"/>
+              </a:rPr>
+              <a:t>종류</a:t>
+            </a:r>
+            <a:pPr indent="0" marL="0">
+              <a:lnSpc>
+                <a:spcPct val="102000"/>
+              </a:lnSpc>
+              <a:buNone/>
+            </a:pPr>
+            <a:r>
+              <a:rPr lang="en-US" sz="1250" dirty="0">
+                <a:solidFill>
+                  <a:srgbClr val="2A2723"/>
+                </a:solidFill>
+                <a:latin typeface="Malgun Gothic" pitchFamily="34" charset="0"/>
+                <a:ea typeface="Malgun Gothic" pitchFamily="34" charset="-122"/>
+                <a:cs typeface="Malgun Gothic" pitchFamily="34" charset="-120"/>
+              </a:rPr>
+              <a:t>로" 벌리는 이유와, </a:t>
+            </a:r>
+            <a:pPr indent="0" marL="0">
+              <a:lnSpc>
+                <a:spcPct val="102000"/>
+              </a:lnSpc>
+              <a:buNone/>
+            </a:pPr>
+            <a:r>
+              <a:rPr lang="en-US" sz="1250" b="1" dirty="0">
+                <a:solidFill>
+                  <a:srgbClr val="2A2723"/>
+                </a:solidFill>
+                <a:latin typeface="Malgun Gothic" pitchFamily="34" charset="0"/>
+                <a:ea typeface="Malgun Gothic" pitchFamily="34" charset="-122"/>
+                <a:cs typeface="Malgun Gothic" pitchFamily="34" charset="-120"/>
+              </a:rPr>
+              <a:t>제외 조건</a:t>
+            </a:r>
+            <a:pPr indent="0" marL="0">
+              <a:lnSpc>
+                <a:spcPct val="102000"/>
+              </a:lnSpc>
+              <a:buNone/>
+            </a:pPr>
+            <a:r>
+              <a:rPr lang="en-US" sz="1250" dirty="0">
+                <a:solidFill>
+                  <a:srgbClr val="2A2723"/>
+                </a:solidFill>
+                <a:latin typeface="Malgun Gothic" pitchFamily="34" charset="0"/>
+                <a:ea typeface="Malgun Gothic" pitchFamily="34" charset="-122"/>
+                <a:cs typeface="Malgun Gothic" pitchFamily="34" charset="-120"/>
+              </a:rPr>
+              <a:t>을 점수보다 먼저 거르는 이유는?</a:t>
+            </a:r>
+            <a:endParaRPr lang="en-US" sz="1250" dirty="0"/>
+          </a:p>
+        </p:txBody>
+      </p:sp>
+      <p:sp>
+        <p:nvSpPr>
+          <p:cNvPr id="13" name="Shape 11"/>
+          <p:cNvSpPr/>
+          <p:nvPr/>
+        </p:nvSpPr>
+        <p:spPr>
+          <a:xfrm>
+            <a:off x="612648" y="2930881"/>
+            <a:ext cx="11027664" cy="437464"/>
+          </a:xfrm>
+          <a:prstGeom prst="roundRect">
+            <a:avLst>
+              <a:gd name="adj" fmla="val 18812"/>
+            </a:avLst>
+          </a:prstGeom>
+          <a:solidFill>
+            <a:srgbClr val="FFFFFF"/>
+          </a:solidFill>
+          <a:ln w="12700">
+            <a:solidFill>
+              <a:srgbClr val="E3DACB"/>
+            </a:solidFill>
+            <a:prstDash val="solid"/>
+          </a:ln>
+        </p:spPr>
+      </p:sp>
+      <p:sp>
+        <p:nvSpPr>
+          <p:cNvPr id="14" name="Shape 12"/>
+          <p:cNvSpPr/>
+          <p:nvPr/>
+        </p:nvSpPr>
+        <p:spPr>
+          <a:xfrm>
+            <a:off x="548640" y="2930881"/>
+            <a:ext cx="64008" cy="437464"/>
+          </a:xfrm>
+          <a:prstGeom prst="rect">
+            <a:avLst/>
+          </a:prstGeom>
+          <a:solidFill>
+            <a:srgbClr val="3F6B5F"/>
+          </a:solidFill>
+          <a:ln/>
+        </p:spPr>
+      </p:sp>
+      <p:sp>
+        <p:nvSpPr>
+          <p:cNvPr id="15" name="Text 13"/>
+          <p:cNvSpPr/>
+          <p:nvPr/>
+        </p:nvSpPr>
+        <p:spPr>
+          <a:xfrm>
+            <a:off x="786384" y="2930881"/>
+            <a:ext cx="10707624" cy="437464"/>
+          </a:xfrm>
+          <a:prstGeom prst="rect">
+            <a:avLst/>
+          </a:prstGeom>
+          <a:noFill/>
+          <a:ln/>
+        </p:spPr>
+        <p:txBody>
+          <a:bodyPr wrap="square" rtlCol="0" anchor="ctr">
+            <a:normAutofit/>
+          </a:bodyPr>
+          <a:lstStyle/>
+          <a:p>
+            <a:pPr indent="0" marL="0">
+              <a:lnSpc>
+                <a:spcPct val="102000"/>
+              </a:lnSpc>
+              <a:buNone/>
+            </a:pPr>
+            <a:r>
+              <a:rPr lang="en-US" sz="1250" b="1" dirty="0">
+                <a:solidFill>
+                  <a:srgbClr val="2A2723"/>
+                </a:solidFill>
+                <a:latin typeface="Malgun Gothic" pitchFamily="34" charset="0"/>
+                <a:ea typeface="Malgun Gothic" pitchFamily="34" charset="-122"/>
+                <a:cs typeface="Malgun Gothic" pitchFamily="34" charset="-120"/>
+              </a:rPr>
+              <a:t>Q4.</a:t>
+            </a:r>
+            <a:pPr indent="0" marL="0">
+              <a:lnSpc>
+                <a:spcPct val="102000"/>
+              </a:lnSpc>
+              <a:buNone/>
+            </a:pPr>
+            <a:r>
+              <a:rPr lang="en-US" sz="1250" dirty="0">
+                <a:solidFill>
+                  <a:srgbClr val="2A2723"/>
+                </a:solidFill>
+                <a:latin typeface="Malgun Gothic" pitchFamily="34" charset="0"/>
+                <a:ea typeface="Malgun Gothic" pitchFamily="34" charset="-122"/>
+                <a:cs typeface="Malgun Gothic" pitchFamily="34" charset="-120"/>
+              </a:rPr>
+              <a:t> 사진 검색기에서 </a:t>
+            </a:r>
+            <a:pPr indent="0" marL="0">
+              <a:lnSpc>
+                <a:spcPct val="102000"/>
+              </a:lnSpc>
+              <a:buNone/>
+            </a:pPr>
+            <a:r>
+              <a:rPr lang="en-US" sz="1250" b="1" dirty="0">
+                <a:solidFill>
+                  <a:srgbClr val="2A2723"/>
+                </a:solidFill>
+                <a:latin typeface="Malgun Gothic" pitchFamily="34" charset="0"/>
+                <a:ea typeface="Malgun Gothic" pitchFamily="34" charset="-122"/>
+                <a:cs typeface="Malgun Gothic" pitchFamily="34" charset="-120"/>
+              </a:rPr>
+              <a:t>"없다"는 답이 순위에서 안 나오는</a:t>
+            </a:r>
+            <a:pPr indent="0" marL="0">
+              <a:lnSpc>
+                <a:spcPct val="102000"/>
+              </a:lnSpc>
+              <a:buNone/>
+            </a:pPr>
+            <a:r>
+              <a:rPr lang="en-US" sz="1250" dirty="0">
+                <a:solidFill>
+                  <a:srgbClr val="2A2723"/>
+                </a:solidFill>
+                <a:latin typeface="Malgun Gothic" pitchFamily="34" charset="0"/>
+                <a:ea typeface="Malgun Gothic" pitchFamily="34" charset="-122"/>
+                <a:cs typeface="Malgun Gothic" pitchFamily="34" charset="-120"/>
+              </a:rPr>
+              <a:t> 이유와, 그것을 가능하게 하는 조건은?</a:t>
+            </a:r>
+            <a:endParaRPr lang="en-US" sz="1250" dirty="0"/>
+          </a:p>
+        </p:txBody>
+      </p:sp>
+      <p:sp>
+        <p:nvSpPr>
+          <p:cNvPr id="16" name="Shape 14"/>
+          <p:cNvSpPr/>
+          <p:nvPr/>
+        </p:nvSpPr>
+        <p:spPr>
+          <a:xfrm>
+            <a:off x="612648" y="3450641"/>
+            <a:ext cx="11027664" cy="437464"/>
+          </a:xfrm>
+          <a:prstGeom prst="roundRect">
+            <a:avLst>
+              <a:gd name="adj" fmla="val 18812"/>
+            </a:avLst>
+          </a:prstGeom>
+          <a:solidFill>
+            <a:srgbClr val="FFFFFF"/>
+          </a:solidFill>
+          <a:ln w="12700">
+            <a:solidFill>
+              <a:srgbClr val="E3DACB"/>
+            </a:solidFill>
+            <a:prstDash val="solid"/>
+          </a:ln>
+        </p:spPr>
+      </p:sp>
+      <p:sp>
+        <p:nvSpPr>
+          <p:cNvPr id="17" name="Shape 15"/>
+          <p:cNvSpPr/>
+          <p:nvPr/>
+        </p:nvSpPr>
+        <p:spPr>
+          <a:xfrm>
+            <a:off x="548640" y="3450641"/>
+            <a:ext cx="64008" cy="437464"/>
+          </a:xfrm>
+          <a:prstGeom prst="rect">
+            <a:avLst/>
+          </a:prstGeom>
+          <a:solidFill>
+            <a:srgbClr val="3F6B5F"/>
+          </a:solidFill>
+          <a:ln/>
+        </p:spPr>
+      </p:sp>
+      <p:sp>
+        <p:nvSpPr>
+          <p:cNvPr id="18" name="Text 16"/>
+          <p:cNvSpPr/>
+          <p:nvPr/>
+        </p:nvSpPr>
+        <p:spPr>
+          <a:xfrm>
+            <a:off x="786384" y="3450641"/>
+            <a:ext cx="10707624" cy="437464"/>
+          </a:xfrm>
+          <a:prstGeom prst="rect">
+            <a:avLst/>
+          </a:prstGeom>
+          <a:noFill/>
+          <a:ln/>
+        </p:spPr>
+        <p:txBody>
+          <a:bodyPr wrap="square" rtlCol="0" anchor="ctr">
+            <a:normAutofit/>
+          </a:bodyPr>
+          <a:lstStyle/>
+          <a:p>
+            <a:pPr indent="0" marL="0">
+              <a:lnSpc>
+                <a:spcPct val="102000"/>
+              </a:lnSpc>
+              <a:buNone/>
+            </a:pPr>
+            <a:r>
+              <a:rPr lang="en-US" sz="1250" b="1" dirty="0">
+                <a:solidFill>
+                  <a:srgbClr val="2A2723"/>
+                </a:solidFill>
+                <a:latin typeface="Malgun Gothic" pitchFamily="34" charset="0"/>
+                <a:ea typeface="Malgun Gothic" pitchFamily="34" charset="-122"/>
+                <a:cs typeface="Malgun Gothic" pitchFamily="34" charset="-120"/>
+              </a:rPr>
+              <a:t>Q5.</a:t>
+            </a:r>
+            <a:pPr indent="0" marL="0">
+              <a:lnSpc>
+                <a:spcPct val="102000"/>
+              </a:lnSpc>
+              <a:buNone/>
+            </a:pPr>
+            <a:r>
+              <a:rPr lang="en-US" sz="1250" dirty="0">
+                <a:solidFill>
+                  <a:srgbClr val="2A2723"/>
+                </a:solidFill>
+                <a:latin typeface="Malgun Gothic" pitchFamily="34" charset="0"/>
+                <a:ea typeface="Malgun Gothic" pitchFamily="34" charset="-122"/>
+                <a:cs typeface="Malgun Gothic" pitchFamily="34" charset="-120"/>
+              </a:rPr>
+              <a:t> "값이 계산된다 ≠ 값이 의도한 것을 잰다"의 </a:t>
+            </a:r>
+            <a:pPr indent="0" marL="0">
+              <a:lnSpc>
+                <a:spcPct val="102000"/>
+              </a:lnSpc>
+              <a:buNone/>
+            </a:pPr>
+            <a:r>
+              <a:rPr lang="en-US" sz="1250" b="1" dirty="0">
+                <a:solidFill>
+                  <a:srgbClr val="2A2723"/>
+                </a:solidFill>
+                <a:latin typeface="Malgun Gothic" pitchFamily="34" charset="0"/>
+                <a:ea typeface="Malgun Gothic" pitchFamily="34" charset="-122"/>
+                <a:cs typeface="Malgun Gothic" pitchFamily="34" charset="-120"/>
+              </a:rPr>
+              <a:t>예</a:t>
+            </a:r>
+            <a:pPr indent="0" marL="0">
+              <a:lnSpc>
+                <a:spcPct val="102000"/>
+              </a:lnSpc>
+              <a:buNone/>
+            </a:pPr>
+            <a:r>
+              <a:rPr lang="en-US" sz="1250" dirty="0">
+                <a:solidFill>
+                  <a:srgbClr val="2A2723"/>
+                </a:solidFill>
+                <a:latin typeface="Malgun Gothic" pitchFamily="34" charset="0"/>
+                <a:ea typeface="Malgun Gothic" pitchFamily="34" charset="-122"/>
+                <a:cs typeface="Malgun Gothic" pitchFamily="34" charset="-120"/>
+              </a:rPr>
+              <a:t>와, </a:t>
+            </a:r>
+            <a:pPr indent="0" marL="0">
+              <a:lnSpc>
+                <a:spcPct val="102000"/>
+              </a:lnSpc>
+              <a:buNone/>
+            </a:pPr>
+            <a:r>
+              <a:rPr lang="en-US" sz="1250" b="1" dirty="0">
+                <a:solidFill>
+                  <a:srgbClr val="2A2723"/>
+                </a:solidFill>
+                <a:latin typeface="Malgun Gothic" pitchFamily="34" charset="0"/>
+                <a:ea typeface="Malgun Gothic" pitchFamily="34" charset="-122"/>
+                <a:cs typeface="Malgun Gothic" pitchFamily="34" charset="-120"/>
+              </a:rPr>
+              <a:t>촬영 방향</a:t>
+            </a:r>
+            <a:pPr indent="0" marL="0">
+              <a:lnSpc>
+                <a:spcPct val="102000"/>
+              </a:lnSpc>
+              <a:buNone/>
+            </a:pPr>
+            <a:r>
+              <a:rPr lang="en-US" sz="1250" dirty="0">
+                <a:solidFill>
+                  <a:srgbClr val="2A2723"/>
+                </a:solidFill>
+                <a:latin typeface="Malgun Gothic" pitchFamily="34" charset="0"/>
+                <a:ea typeface="Malgun Gothic" pitchFamily="34" charset="-122"/>
+                <a:cs typeface="Malgun Gothic" pitchFamily="34" charset="-120"/>
+              </a:rPr>
+              <a:t>이 판정을 정한다는 뜻은?</a:t>
+            </a:r>
+            <a:endParaRPr lang="en-US" sz="1250" dirty="0"/>
+          </a:p>
+        </p:txBody>
+      </p:sp>
+    </p:spTree>
+  </p:cSld>
+  <p:clrMapOvr>
+    <a:masterClrMapping/>
+  </p:clrMapOvr>
+</p:sld>
+</file>
+
+<file path=ppt/slides/slide32.xml><?xml version="1.0" encoding="utf-8"?>
+<p:sld xmlns:a="http://schemas.openxmlformats.org/drawingml/2006/main" xmlns:r="http://schemas.openxmlformats.org/officeDocument/2006/relationships" xmlns:p="http://schemas.openxmlformats.org/presentationml/2006/main">
+  <p:cSld name="Slide 32">
+    <p:bg>
+      <p:bgPr>
+        <a:solidFill>
+          <a:srgbClr val="FAF8F4"/>
+        </a:solidFill>
+      </p:bgPr>
+    </p:bg>
+    <p:spTree>
+      <p:nvGrpSpPr>
+        <p:cNvPr id="1" name=""/>
+        <p:cNvGrpSpPr/>
+        <p:nvPr/>
+      </p:nvGrpSpPr>
+      <p:grpSpPr>
+        <a:xfrm>
+          <a:off x="0" y="0"/>
+          <a:ext cx="0" cy="0"/>
+          <a:chOff x="0" y="0"/>
+          <a:chExt cx="0" cy="0"/>
+        </a:xfrm>
+      </p:grpSpPr>
+      <p:sp>
+        <p:nvSpPr>
+          <p:cNvPr id="2" name="Text 0"/>
+          <p:cNvSpPr/>
+          <p:nvPr/>
+        </p:nvSpPr>
+        <p:spPr>
+          <a:xfrm>
+            <a:off x="548640" y="384048"/>
+            <a:ext cx="11091672" cy="731520"/>
+          </a:xfrm>
+          <a:prstGeom prst="rect">
+            <a:avLst/>
+          </a:prstGeom>
+          <a:noFill/>
+          <a:ln/>
+        </p:spPr>
+        <p:txBody>
+          <a:bodyPr wrap="square" rtlCol="0" anchor="ctr">
+            <a:normAutofit/>
+          </a:bodyPr>
+          <a:lstStyle/>
+          <a:p>
+            <a:pPr indent="0" marL="0">
+              <a:buNone/>
+            </a:pPr>
+            <a:r>
+              <a:rPr lang="en-US" sz="2400" b="1" dirty="0">
+                <a:solidFill>
+                  <a:srgbClr val="2A2723"/>
+                </a:solidFill>
+                <a:latin typeface="Malgun Gothic" pitchFamily="34" charset="0"/>
+                <a:ea typeface="Malgun Gothic" pitchFamily="34" charset="-122"/>
+                <a:cs typeface="Malgun Gothic" pitchFamily="34" charset="-120"/>
+              </a:rPr>
+              <a:t>✅ 정답 &amp; 해설</a:t>
+            </a:r>
+            <a:endParaRPr lang="en-US" sz="2400" dirty="0"/>
+          </a:p>
+        </p:txBody>
+      </p:sp>
+      <p:sp>
+        <p:nvSpPr>
+          <p:cNvPr id="3" name="Shape 1"/>
+          <p:cNvSpPr/>
+          <p:nvPr/>
+        </p:nvSpPr>
+        <p:spPr>
+          <a:xfrm>
+            <a:off x="566928" y="1133856"/>
+            <a:ext cx="777240" cy="41148"/>
+          </a:xfrm>
+          <a:prstGeom prst="rect">
+            <a:avLst/>
+          </a:prstGeom>
+          <a:solidFill>
+            <a:srgbClr val="3F6B5F"/>
+          </a:solidFill>
+          <a:ln/>
+        </p:spPr>
+      </p:sp>
+      <p:sp>
+        <p:nvSpPr>
+          <p:cNvPr id="4" name="Shape 2"/>
+          <p:cNvSpPr/>
+          <p:nvPr/>
+        </p:nvSpPr>
+        <p:spPr>
+          <a:xfrm>
+            <a:off x="612648" y="1371600"/>
+            <a:ext cx="11027664" cy="627964"/>
+          </a:xfrm>
+          <a:prstGeom prst="roundRect">
+            <a:avLst>
+              <a:gd name="adj" fmla="val 13105"/>
+            </a:avLst>
+          </a:prstGeom>
+          <a:solidFill>
+            <a:srgbClr val="FFFFFF"/>
+          </a:solidFill>
+          <a:ln w="12700">
+            <a:solidFill>
+              <a:srgbClr val="E3DACB"/>
+            </a:solidFill>
+            <a:prstDash val="solid"/>
+          </a:ln>
+        </p:spPr>
+      </p:sp>
+      <p:sp>
+        <p:nvSpPr>
+          <p:cNvPr id="5" name="Shape 3"/>
+          <p:cNvSpPr/>
+          <p:nvPr/>
+        </p:nvSpPr>
+        <p:spPr>
+          <a:xfrm>
+            <a:off x="548640" y="1371600"/>
+            <a:ext cx="64008" cy="627964"/>
+          </a:xfrm>
+          <a:prstGeom prst="rect">
+            <a:avLst/>
+          </a:prstGeom>
+          <a:solidFill>
+            <a:srgbClr val="C8A15A"/>
+          </a:solidFill>
+          <a:ln/>
+        </p:spPr>
+      </p:sp>
+      <p:sp>
+        <p:nvSpPr>
+          <p:cNvPr id="6" name="Text 4"/>
+          <p:cNvSpPr/>
+          <p:nvPr/>
+        </p:nvSpPr>
+        <p:spPr>
+          <a:xfrm>
+            <a:off x="786384" y="1371600"/>
+            <a:ext cx="10707624" cy="627964"/>
+          </a:xfrm>
+          <a:prstGeom prst="rect">
+            <a:avLst/>
+          </a:prstGeom>
+          <a:noFill/>
+          <a:ln/>
+        </p:spPr>
+        <p:txBody>
+          <a:bodyPr wrap="square" rtlCol="0" anchor="ctr">
+            <a:normAutofit/>
+          </a:bodyPr>
+          <a:lstStyle/>
+          <a:p>
+            <a:pPr indent="0" marL="0">
+              <a:lnSpc>
+                <a:spcPct val="102000"/>
+              </a:lnSpc>
+              <a:buNone/>
+            </a:pPr>
+            <a:r>
+              <a:rPr lang="en-US" sz="1250" b="1" dirty="0">
+                <a:solidFill>
+                  <a:srgbClr val="2A2723"/>
+                </a:solidFill>
+                <a:latin typeface="Malgun Gothic" pitchFamily="34" charset="0"/>
+                <a:ea typeface="Malgun Gothic" pitchFamily="34" charset="-122"/>
+                <a:cs typeface="Malgun Gothic" pitchFamily="34" charset="-120"/>
+              </a:rPr>
+              <a:t>A1.</a:t>
+            </a:r>
+            <a:pPr indent="0" marL="0">
+              <a:lnSpc>
+                <a:spcPct val="102000"/>
+              </a:lnSpc>
+              <a:buNone/>
+            </a:pPr>
+            <a:r>
+              <a:rPr lang="en-US" sz="1250" dirty="0">
+                <a:solidFill>
+                  <a:srgbClr val="2A2723"/>
+                </a:solidFill>
+                <a:latin typeface="Malgun Gothic" pitchFamily="34" charset="0"/>
+                <a:ea typeface="Malgun Gothic" pitchFamily="34" charset="-122"/>
+                <a:cs typeface="Malgun Gothic" pitchFamily="34" charset="-120"/>
+              </a:rPr>
+              <a:t> 완성품=</a:t>
+            </a:r>
+            <a:pPr indent="0" marL="0">
+              <a:lnSpc>
+                <a:spcPct val="102000"/>
+              </a:lnSpc>
+              <a:buNone/>
+            </a:pPr>
+            <a:r>
+              <a:rPr lang="en-US" sz="1250" b="1" dirty="0">
+                <a:solidFill>
+                  <a:srgbClr val="2A2723"/>
+                </a:solidFill>
+                <a:latin typeface="Malgun Gothic" pitchFamily="34" charset="0"/>
+                <a:ea typeface="Malgun Gothic" pitchFamily="34" charset="-122"/>
+                <a:cs typeface="Malgun Gothic" pitchFamily="34" charset="-120"/>
+              </a:rPr>
+              <a:t>쓰이는 것</a:t>
+            </a:r>
+            <a:pPr indent="0" marL="0">
+              <a:lnSpc>
+                <a:spcPct val="102000"/>
+              </a:lnSpc>
+              <a:buNone/>
+            </a:pPr>
+            <a:r>
+              <a:rPr lang="en-US" sz="1250" dirty="0">
+                <a:solidFill>
+                  <a:srgbClr val="2A2723"/>
+                </a:solidFill>
+                <a:latin typeface="Malgun Gothic" pitchFamily="34" charset="0"/>
+                <a:ea typeface="Malgun Gothic" pitchFamily="34" charset="-122"/>
+                <a:cs typeface="Malgun Gothic" pitchFamily="34" charset="-120"/>
+              </a:rPr>
+              <a:t>, PoC=</a:t>
+            </a:r>
+            <a:pPr indent="0" marL="0">
+              <a:lnSpc>
+                <a:spcPct val="102000"/>
+              </a:lnSpc>
+              <a:buNone/>
+            </a:pPr>
+            <a:r>
+              <a:rPr lang="en-US" sz="1250" b="1" dirty="0">
+                <a:solidFill>
+                  <a:srgbClr val="2A2723"/>
+                </a:solidFill>
+                <a:latin typeface="Malgun Gothic" pitchFamily="34" charset="0"/>
+                <a:ea typeface="Malgun Gothic" pitchFamily="34" charset="-122"/>
+                <a:cs typeface="Malgun Gothic" pitchFamily="34" charset="-120"/>
+              </a:rPr>
+              <a:t>판단이 서는 것</a:t>
+            </a:r>
+            <a:pPr indent="0" marL="0">
+              <a:lnSpc>
+                <a:spcPct val="102000"/>
+              </a:lnSpc>
+              <a:buNone/>
+            </a:pPr>
+            <a:r>
+              <a:rPr lang="en-US" sz="1250" dirty="0">
+                <a:solidFill>
+                  <a:srgbClr val="2A2723"/>
+                </a:solidFill>
+                <a:latin typeface="Malgun Gothic" pitchFamily="34" charset="0"/>
+                <a:ea typeface="Malgun Gothic" pitchFamily="34" charset="-122"/>
+                <a:cs typeface="Malgun Gothic" pitchFamily="34" charset="-120"/>
+              </a:rPr>
+              <a:t>. 산출물은 작동하는 물건이 아니라 </a:t>
+            </a:r>
+            <a:pPr indent="0" marL="0">
+              <a:lnSpc>
+                <a:spcPct val="102000"/>
+              </a:lnSpc>
+              <a:buNone/>
+            </a:pPr>
+            <a:r>
+              <a:rPr lang="en-US" sz="1250" b="1" dirty="0">
+                <a:solidFill>
+                  <a:srgbClr val="2A2723"/>
+                </a:solidFill>
+                <a:latin typeface="Malgun Gothic" pitchFamily="34" charset="0"/>
+                <a:ea typeface="Malgun Gothic" pitchFamily="34" charset="-122"/>
+                <a:cs typeface="Malgun Gothic" pitchFamily="34" charset="-120"/>
+              </a:rPr>
+              <a:t>판단</a:t>
+            </a:r>
+            <a:pPr indent="0" marL="0">
+              <a:lnSpc>
+                <a:spcPct val="102000"/>
+              </a:lnSpc>
+              <a:buNone/>
+            </a:pPr>
+            <a:r>
+              <a:rPr lang="en-US" sz="1250" dirty="0">
+                <a:solidFill>
+                  <a:srgbClr val="2A2723"/>
+                </a:solidFill>
+                <a:latin typeface="Malgun Gothic" pitchFamily="34" charset="0"/>
+                <a:ea typeface="Malgun Gothic" pitchFamily="34" charset="-122"/>
+                <a:cs typeface="Malgun Gothic" pitchFamily="34" charset="-120"/>
+              </a:rPr>
+              <a:t> — 기준을 넘으면 구축, 못 넘으면 그 이유(둘 다 성과).</a:t>
+            </a:r>
+            <a:endParaRPr lang="en-US" sz="1250" dirty="0"/>
+          </a:p>
+        </p:txBody>
+      </p:sp>
+      <p:sp>
+        <p:nvSpPr>
+          <p:cNvPr id="7" name="Shape 5"/>
+          <p:cNvSpPr/>
+          <p:nvPr/>
+        </p:nvSpPr>
+        <p:spPr>
+          <a:xfrm>
+            <a:off x="612648" y="2081860"/>
+            <a:ext cx="11027664" cy="627964"/>
+          </a:xfrm>
+          <a:prstGeom prst="roundRect">
+            <a:avLst>
+              <a:gd name="adj" fmla="val 13105"/>
+            </a:avLst>
+          </a:prstGeom>
+          <a:solidFill>
+            <a:srgbClr val="FFFFFF"/>
+          </a:solidFill>
+          <a:ln w="12700">
+            <a:solidFill>
+              <a:srgbClr val="E3DACB"/>
+            </a:solidFill>
+            <a:prstDash val="solid"/>
+          </a:ln>
+        </p:spPr>
+      </p:sp>
+      <p:sp>
+        <p:nvSpPr>
+          <p:cNvPr id="8" name="Shape 6"/>
+          <p:cNvSpPr/>
+          <p:nvPr/>
+        </p:nvSpPr>
+        <p:spPr>
+          <a:xfrm>
+            <a:off x="548640" y="2081860"/>
+            <a:ext cx="64008" cy="627964"/>
+          </a:xfrm>
+          <a:prstGeom prst="rect">
+            <a:avLst/>
+          </a:prstGeom>
+          <a:solidFill>
+            <a:srgbClr val="C8A15A"/>
+          </a:solidFill>
+          <a:ln/>
+        </p:spPr>
+      </p:sp>
+      <p:sp>
+        <p:nvSpPr>
+          <p:cNvPr id="9" name="Text 7"/>
+          <p:cNvSpPr/>
+          <p:nvPr/>
+        </p:nvSpPr>
+        <p:spPr>
+          <a:xfrm>
+            <a:off x="786384" y="2081860"/>
+            <a:ext cx="10707624" cy="627964"/>
+          </a:xfrm>
+          <a:prstGeom prst="rect">
+            <a:avLst/>
+          </a:prstGeom>
+          <a:noFill/>
+          <a:ln/>
+        </p:spPr>
+        <p:txBody>
+          <a:bodyPr wrap="square" rtlCol="0" anchor="ctr">
+            <a:normAutofit/>
+          </a:bodyPr>
+          <a:lstStyle/>
+          <a:p>
+            <a:pPr indent="0" marL="0">
+              <a:lnSpc>
+                <a:spcPct val="102000"/>
+              </a:lnSpc>
+              <a:buNone/>
+            </a:pPr>
+            <a:r>
+              <a:rPr lang="en-US" sz="1250" b="1" dirty="0">
+                <a:solidFill>
+                  <a:srgbClr val="2A2723"/>
+                </a:solidFill>
+                <a:latin typeface="Malgun Gothic" pitchFamily="34" charset="0"/>
+                <a:ea typeface="Malgun Gothic" pitchFamily="34" charset="-122"/>
+                <a:cs typeface="Malgun Gothic" pitchFamily="34" charset="-120"/>
+              </a:rPr>
+              <a:t>A2.</a:t>
+            </a:r>
+            <a:pPr indent="0" marL="0">
+              <a:lnSpc>
+                <a:spcPct val="102000"/>
+              </a:lnSpc>
+              <a:buNone/>
+            </a:pPr>
+            <a:r>
+              <a:rPr lang="en-US" sz="1250" dirty="0">
+                <a:solidFill>
+                  <a:srgbClr val="2A2723"/>
+                </a:solidFill>
+                <a:latin typeface="Malgun Gothic" pitchFamily="34" charset="0"/>
+                <a:ea typeface="Malgun Gothic" pitchFamily="34" charset="-122"/>
+                <a:cs typeface="Malgun Gothic" pitchFamily="34" charset="-120"/>
+              </a:rPr>
+              <a:t> 검색(설명 없음)·검사판독(일관성·지속 시간)·분류배분(판단의 총량)·입력전사(손). 검사·판독은 </a:t>
+            </a:r>
+            <a:pPr indent="0" marL="0">
+              <a:lnSpc>
+                <a:spcPct val="102000"/>
+              </a:lnSpc>
+              <a:buNone/>
+            </a:pPr>
+            <a:r>
+              <a:rPr lang="en-US" sz="1250" b="1" dirty="0">
+                <a:solidFill>
+                  <a:srgbClr val="2A2723"/>
+                </a:solidFill>
+                <a:latin typeface="Malgun Gothic" pitchFamily="34" charset="0"/>
+                <a:ea typeface="Malgun Gothic" pitchFamily="34" charset="-122"/>
+                <a:cs typeface="Malgun Gothic" pitchFamily="34" charset="-120"/>
+              </a:rPr>
+              <a:t>정확도는 사람이 더 높은 경우가 많아</a:t>
+            </a:r>
+            <a:pPr indent="0" marL="0">
+              <a:lnSpc>
+                <a:spcPct val="102000"/>
+              </a:lnSpc>
+              <a:buNone/>
+            </a:pPr>
+            <a:r>
+              <a:rPr lang="en-US" sz="1250" dirty="0">
+                <a:solidFill>
+                  <a:srgbClr val="2A2723"/>
+                </a:solidFill>
+                <a:latin typeface="Malgun Gothic" pitchFamily="34" charset="0"/>
+                <a:ea typeface="Malgun Gothic" pitchFamily="34" charset="-122"/>
+                <a:cs typeface="Malgun Gothic" pitchFamily="34" charset="-120"/>
+              </a:rPr>
+              <a:t>, 정확도로 잡으면 "도입할 값 없음"이 나온다.</a:t>
+            </a:r>
+            <a:endParaRPr lang="en-US" sz="1250" dirty="0"/>
+          </a:p>
+        </p:txBody>
+      </p:sp>
+      <p:sp>
+        <p:nvSpPr>
+          <p:cNvPr id="10" name="Shape 8"/>
+          <p:cNvSpPr/>
+          <p:nvPr/>
+        </p:nvSpPr>
+        <p:spPr>
+          <a:xfrm>
+            <a:off x="612648" y="2792120"/>
+            <a:ext cx="11027664" cy="627964"/>
+          </a:xfrm>
+          <a:prstGeom prst="roundRect">
+            <a:avLst>
+              <a:gd name="adj" fmla="val 13105"/>
+            </a:avLst>
+          </a:prstGeom>
+          <a:solidFill>
+            <a:srgbClr val="FFFFFF"/>
+          </a:solidFill>
+          <a:ln w="12700">
+            <a:solidFill>
+              <a:srgbClr val="E3DACB"/>
+            </a:solidFill>
+            <a:prstDash val="solid"/>
+          </a:ln>
+        </p:spPr>
+      </p:sp>
+      <p:sp>
+        <p:nvSpPr>
+          <p:cNvPr id="11" name="Shape 9"/>
+          <p:cNvSpPr/>
+          <p:nvPr/>
+        </p:nvSpPr>
+        <p:spPr>
+          <a:xfrm>
+            <a:off x="548640" y="2792120"/>
+            <a:ext cx="64008" cy="627964"/>
+          </a:xfrm>
+          <a:prstGeom prst="rect">
+            <a:avLst/>
+          </a:prstGeom>
+          <a:solidFill>
+            <a:srgbClr val="C8A15A"/>
+          </a:solidFill>
+          <a:ln/>
+        </p:spPr>
+      </p:sp>
+      <p:sp>
+        <p:nvSpPr>
+          <p:cNvPr id="12" name="Text 10"/>
+          <p:cNvSpPr/>
+          <p:nvPr/>
+        </p:nvSpPr>
+        <p:spPr>
+          <a:xfrm>
+            <a:off x="786384" y="2792120"/>
+            <a:ext cx="10707624" cy="627964"/>
+          </a:xfrm>
+          <a:prstGeom prst="rect">
+            <a:avLst/>
+          </a:prstGeom>
+          <a:noFill/>
+          <a:ln/>
+        </p:spPr>
+        <p:txBody>
+          <a:bodyPr wrap="square" rtlCol="0" anchor="ctr">
+            <a:normAutofit/>
+          </a:bodyPr>
+          <a:lstStyle/>
+          <a:p>
+            <a:pPr indent="0" marL="0">
+              <a:lnSpc>
+                <a:spcPct val="102000"/>
+              </a:lnSpc>
+              <a:buNone/>
+            </a:pPr>
+            <a:r>
+              <a:rPr lang="en-US" sz="1250" b="1" dirty="0">
+                <a:solidFill>
+                  <a:srgbClr val="2A2723"/>
+                </a:solidFill>
+                <a:latin typeface="Malgun Gothic" pitchFamily="34" charset="0"/>
+                <a:ea typeface="Malgun Gothic" pitchFamily="34" charset="-122"/>
+                <a:cs typeface="Malgun Gothic" pitchFamily="34" charset="-120"/>
+              </a:rPr>
+              <a:t>A3.</a:t>
+            </a:r>
+            <a:pPr indent="0" marL="0">
+              <a:lnSpc>
+                <a:spcPct val="102000"/>
+              </a:lnSpc>
+              <a:buNone/>
+            </a:pPr>
+            <a:r>
+              <a:rPr lang="en-US" sz="1250" dirty="0">
+                <a:solidFill>
+                  <a:srgbClr val="2A2723"/>
+                </a:solidFill>
+                <a:latin typeface="Malgun Gothic" pitchFamily="34" charset="0"/>
+                <a:ea typeface="Malgun Gothic" pitchFamily="34" charset="-122"/>
+                <a:cs typeface="Malgun Gothic" pitchFamily="34" charset="-120"/>
+              </a:rPr>
+              <a:t> 대·중·소는 </a:t>
+            </a:r>
+            <a:pPr indent="0" marL="0">
+              <a:lnSpc>
+                <a:spcPct val="102000"/>
+              </a:lnSpc>
+              <a:buNone/>
+            </a:pPr>
+            <a:r>
+              <a:rPr lang="en-US" sz="1250" b="1" dirty="0">
+                <a:solidFill>
+                  <a:srgbClr val="2A2723"/>
+                </a:solidFill>
+                <a:latin typeface="Malgun Gothic" pitchFamily="34" charset="0"/>
+                <a:ea typeface="Malgun Gothic" pitchFamily="34" charset="-122"/>
+                <a:cs typeface="Malgun Gothic" pitchFamily="34" charset="-120"/>
+              </a:rPr>
+              <a:t>크기 차이만</a:t>
+            </a:r>
+            <a:pPr indent="0" marL="0">
+              <a:lnSpc>
+                <a:spcPct val="102000"/>
+              </a:lnSpc>
+              <a:buNone/>
+            </a:pPr>
+            <a:r>
+              <a:rPr lang="en-US" sz="1250" dirty="0">
+                <a:solidFill>
+                  <a:srgbClr val="2A2723"/>
+                </a:solidFill>
+                <a:latin typeface="Malgun Gothic" pitchFamily="34" charset="0"/>
+                <a:ea typeface="Malgun Gothic" pitchFamily="34" charset="-122"/>
+                <a:cs typeface="Malgun Gothic" pitchFamily="34" charset="-120"/>
+              </a:rPr>
+              <a:t> 나온다(재 보기 전에도 앎). 실행 위치·목적·결과 형태로 벌려야 </a:t>
+            </a:r>
+            <a:pPr indent="0" marL="0">
+              <a:lnSpc>
+                <a:spcPct val="102000"/>
+              </a:lnSpc>
+              <a:buNone/>
+            </a:pPr>
+            <a:r>
+              <a:rPr lang="en-US" sz="1250" b="1" dirty="0">
+                <a:solidFill>
+                  <a:srgbClr val="2A2723"/>
+                </a:solidFill>
+                <a:latin typeface="Malgun Gothic" pitchFamily="34" charset="0"/>
+                <a:ea typeface="Malgun Gothic" pitchFamily="34" charset="-122"/>
+                <a:cs typeface="Malgun Gothic" pitchFamily="34" charset="-120"/>
+              </a:rPr>
+              <a:t>자료 유출·적합성</a:t>
+            </a:r>
+            <a:pPr indent="0" marL="0">
+              <a:lnSpc>
+                <a:spcPct val="102000"/>
+              </a:lnSpc>
+              <a:buNone/>
+            </a:pPr>
+            <a:r>
+              <a:rPr lang="en-US" sz="1250" dirty="0">
+                <a:solidFill>
+                  <a:srgbClr val="2A2723"/>
+                </a:solidFill>
+                <a:latin typeface="Malgun Gothic" pitchFamily="34" charset="0"/>
+                <a:ea typeface="Malgun Gothic" pitchFamily="34" charset="-122"/>
+                <a:cs typeface="Malgun Gothic" pitchFamily="34" charset="-120"/>
+              </a:rPr>
+              <a:t> 차이가 드러난다. 제외 조건을 점수와 섞으면 </a:t>
+            </a:r>
+            <a:pPr indent="0" marL="0">
+              <a:lnSpc>
+                <a:spcPct val="102000"/>
+              </a:lnSpc>
+              <a:buNone/>
+            </a:pPr>
+            <a:r>
+              <a:rPr lang="en-US" sz="1250" b="1" dirty="0">
+                <a:solidFill>
+                  <a:srgbClr val="2A2723"/>
+                </a:solidFill>
+                <a:latin typeface="Malgun Gothic" pitchFamily="34" charset="0"/>
+                <a:ea typeface="Malgun Gothic" pitchFamily="34" charset="-122"/>
+                <a:cs typeface="Malgun Gothic" pitchFamily="34" charset="-120"/>
+              </a:rPr>
+              <a:t>쓸 수 없는 후보가 1위</a:t>
+            </a:r>
+            <a:pPr indent="0" marL="0">
+              <a:lnSpc>
+                <a:spcPct val="102000"/>
+              </a:lnSpc>
+              <a:buNone/>
+            </a:pPr>
+            <a:r>
+              <a:rPr lang="en-US" sz="1250" dirty="0">
+                <a:solidFill>
+                  <a:srgbClr val="2A2723"/>
+                </a:solidFill>
+                <a:latin typeface="Malgun Gothic" pitchFamily="34" charset="0"/>
+                <a:ea typeface="Malgun Gothic" pitchFamily="34" charset="-122"/>
+                <a:cs typeface="Malgun Gothic" pitchFamily="34" charset="-120"/>
+              </a:rPr>
+              <a:t>가 되고 유출이 각주로 밀린다.</a:t>
+            </a:r>
+            <a:endParaRPr lang="en-US" sz="1250" dirty="0"/>
+          </a:p>
+        </p:txBody>
+      </p:sp>
+      <p:sp>
+        <p:nvSpPr>
+          <p:cNvPr id="13" name="Shape 11"/>
+          <p:cNvSpPr/>
+          <p:nvPr/>
+        </p:nvSpPr>
+        <p:spPr>
+          <a:xfrm>
+            <a:off x="612648" y="3502381"/>
+            <a:ext cx="11027664" cy="627964"/>
+          </a:xfrm>
+          <a:prstGeom prst="roundRect">
+            <a:avLst>
+              <a:gd name="adj" fmla="val 13105"/>
+            </a:avLst>
+          </a:prstGeom>
+          <a:solidFill>
+            <a:srgbClr val="FFFFFF"/>
+          </a:solidFill>
+          <a:ln w="12700">
+            <a:solidFill>
+              <a:srgbClr val="E3DACB"/>
+            </a:solidFill>
+            <a:prstDash val="solid"/>
+          </a:ln>
+        </p:spPr>
+      </p:sp>
+      <p:sp>
+        <p:nvSpPr>
+          <p:cNvPr id="14" name="Shape 12"/>
+          <p:cNvSpPr/>
+          <p:nvPr/>
+        </p:nvSpPr>
+        <p:spPr>
+          <a:xfrm>
+            <a:off x="548640" y="3502381"/>
+            <a:ext cx="64008" cy="627964"/>
+          </a:xfrm>
+          <a:prstGeom prst="rect">
+            <a:avLst/>
+          </a:prstGeom>
+          <a:solidFill>
+            <a:srgbClr val="C8A15A"/>
+          </a:solidFill>
+          <a:ln/>
+        </p:spPr>
+      </p:sp>
+      <p:sp>
+        <p:nvSpPr>
+          <p:cNvPr id="15" name="Text 13"/>
+          <p:cNvSpPr/>
+          <p:nvPr/>
+        </p:nvSpPr>
+        <p:spPr>
+          <a:xfrm>
+            <a:off x="786384" y="3502381"/>
+            <a:ext cx="10707624" cy="627964"/>
+          </a:xfrm>
+          <a:prstGeom prst="rect">
+            <a:avLst/>
+          </a:prstGeom>
+          <a:noFill/>
+          <a:ln/>
+        </p:spPr>
+        <p:txBody>
+          <a:bodyPr wrap="square" rtlCol="0" anchor="ctr">
+            <a:normAutofit/>
+          </a:bodyPr>
+          <a:lstStyle/>
+          <a:p>
+            <a:pPr indent="0" marL="0">
+              <a:lnSpc>
+                <a:spcPct val="102000"/>
+              </a:lnSpc>
+              <a:buNone/>
+            </a:pPr>
+            <a:r>
+              <a:rPr lang="en-US" sz="1250" b="1" dirty="0">
+                <a:solidFill>
+                  <a:srgbClr val="2A2723"/>
+                </a:solidFill>
+                <a:latin typeface="Malgun Gothic" pitchFamily="34" charset="0"/>
+                <a:ea typeface="Malgun Gothic" pitchFamily="34" charset="-122"/>
+                <a:cs typeface="Malgun Gothic" pitchFamily="34" charset="-120"/>
+              </a:rPr>
+              <a:t>A4.</a:t>
+            </a:r>
+            <a:pPr indent="0" marL="0">
+              <a:lnSpc>
+                <a:spcPct val="102000"/>
+              </a:lnSpc>
+              <a:buNone/>
+            </a:pPr>
+            <a:r>
+              <a:rPr lang="en-US" sz="1250" dirty="0">
+                <a:solidFill>
+                  <a:srgbClr val="2A2723"/>
+                </a:solidFill>
+                <a:latin typeface="Malgun Gothic" pitchFamily="34" charset="0"/>
+                <a:ea typeface="Malgun Gothic" pitchFamily="34" charset="-122"/>
+                <a:cs typeface="Malgun Gothic" pitchFamily="34" charset="-120"/>
+              </a:rPr>
+              <a:t> </a:t>
+            </a:r>
+            <a:pPr indent="0" marL="0">
+              <a:lnSpc>
+                <a:spcPct val="102000"/>
+              </a:lnSpc>
+              <a:buNone/>
+            </a:pPr>
+            <a:r>
+              <a:rPr lang="en-US" sz="1250" b="1" dirty="0">
+                <a:solidFill>
+                  <a:srgbClr val="2A2723"/>
+                </a:solidFill>
+                <a:latin typeface="Malgun Gothic" pitchFamily="34" charset="0"/>
+                <a:ea typeface="Malgun Gothic" pitchFamily="34" charset="-122"/>
+                <a:cs typeface="Malgun Gothic" pitchFamily="34" charset="-120"/>
+              </a:rPr>
+              <a:t>softmax</a:t>
+            </a:r>
+            <a:pPr indent="0" marL="0">
+              <a:lnSpc>
+                <a:spcPct val="102000"/>
+              </a:lnSpc>
+              <a:buNone/>
+            </a:pPr>
+            <a:r>
+              <a:rPr lang="en-US" sz="1250" dirty="0">
+                <a:solidFill>
+                  <a:srgbClr val="2A2723"/>
+                </a:solidFill>
+                <a:latin typeface="Malgun Gothic" pitchFamily="34" charset="0"/>
+                <a:ea typeface="Malgun Gothic" pitchFamily="34" charset="-122"/>
+                <a:cs typeface="Malgun Gothic" pitchFamily="34" charset="-120"/>
+              </a:rPr>
+              <a:t>는 합을 1로 만들어 "전부 아니다"가 표현될 자리가 없다(반드시 하나가 최고). "없다"엔 </a:t>
+            </a:r>
+            <a:pPr indent="0" marL="0">
+              <a:lnSpc>
+                <a:spcPct val="102000"/>
+              </a:lnSpc>
+              <a:buNone/>
+            </a:pPr>
+            <a:r>
+              <a:rPr lang="en-US" sz="1250" b="1" dirty="0">
+                <a:solidFill>
+                  <a:srgbClr val="2A2723"/>
+                </a:solidFill>
+                <a:latin typeface="Malgun Gothic" pitchFamily="34" charset="0"/>
+                <a:ea typeface="Malgun Gothic" pitchFamily="34" charset="-122"/>
+                <a:cs typeface="Malgun Gothic" pitchFamily="34" charset="-120"/>
+              </a:rPr>
+              <a:t>임계값</a:t>
+            </a:r>
+            <a:pPr indent="0" marL="0">
+              <a:lnSpc>
+                <a:spcPct val="102000"/>
+              </a:lnSpc>
+              <a:buNone/>
+            </a:pPr>
+            <a:r>
+              <a:rPr lang="en-US" sz="1250" dirty="0">
+                <a:solidFill>
+                  <a:srgbClr val="2A2723"/>
+                </a:solidFill>
+                <a:latin typeface="Malgun Gothic" pitchFamily="34" charset="0"/>
+                <a:ea typeface="Malgun Gothic" pitchFamily="34" charset="-122"/>
+                <a:cs typeface="Malgun Gothic" pitchFamily="34" charset="-120"/>
+              </a:rPr>
+              <a:t>이 필요하고, 임계값은 점수가 </a:t>
+            </a:r>
+            <a:pPr indent="0" marL="0">
+              <a:lnSpc>
+                <a:spcPct val="102000"/>
+              </a:lnSpc>
+              <a:buNone/>
+            </a:pPr>
+            <a:r>
+              <a:rPr lang="en-US" sz="1250" b="1" dirty="0">
+                <a:solidFill>
+                  <a:srgbClr val="2A2723"/>
+                </a:solidFill>
+                <a:latin typeface="Malgun Gothic" pitchFamily="34" charset="0"/>
+                <a:ea typeface="Malgun Gothic" pitchFamily="34" charset="-122"/>
+                <a:cs typeface="Malgun Gothic" pitchFamily="34" charset="-120"/>
+              </a:rPr>
+              <a:t>순위용이 아니라 짝마다 독립된 값</a:t>
+            </a:r>
+            <a:pPr indent="0" marL="0">
+              <a:lnSpc>
+                <a:spcPct val="102000"/>
+              </a:lnSpc>
+              <a:buNone/>
+            </a:pPr>
+            <a:r>
+              <a:rPr lang="en-US" sz="1250" dirty="0">
+                <a:solidFill>
+                  <a:srgbClr val="2A2723"/>
+                </a:solidFill>
+                <a:latin typeface="Malgun Gothic" pitchFamily="34" charset="0"/>
+                <a:ea typeface="Malgun Gothic" pitchFamily="34" charset="-122"/>
+                <a:cs typeface="Malgun Gothic" pitchFamily="34" charset="-120"/>
+              </a:rPr>
+              <a:t>(SigLIP처럼 학습)일 때만 걸 수 있다.</a:t>
+            </a:r>
+            <a:endParaRPr lang="en-US" sz="1250" dirty="0"/>
+          </a:p>
+        </p:txBody>
+      </p:sp>
+      <p:sp>
+        <p:nvSpPr>
+          <p:cNvPr id="16" name="Shape 14"/>
+          <p:cNvSpPr/>
+          <p:nvPr/>
+        </p:nvSpPr>
+        <p:spPr>
+          <a:xfrm>
+            <a:off x="612648" y="4212641"/>
+            <a:ext cx="11027664" cy="627964"/>
+          </a:xfrm>
+          <a:prstGeom prst="roundRect">
+            <a:avLst>
+              <a:gd name="adj" fmla="val 13105"/>
+            </a:avLst>
+          </a:prstGeom>
+          <a:solidFill>
+            <a:srgbClr val="FFFFFF"/>
+          </a:solidFill>
+          <a:ln w="12700">
+            <a:solidFill>
+              <a:srgbClr val="E3DACB"/>
+            </a:solidFill>
+            <a:prstDash val="solid"/>
+          </a:ln>
+        </p:spPr>
+      </p:sp>
+      <p:sp>
+        <p:nvSpPr>
+          <p:cNvPr id="17" name="Shape 15"/>
+          <p:cNvSpPr/>
+          <p:nvPr/>
+        </p:nvSpPr>
+        <p:spPr>
+          <a:xfrm>
+            <a:off x="548640" y="4212641"/>
+            <a:ext cx="64008" cy="627964"/>
+          </a:xfrm>
+          <a:prstGeom prst="rect">
+            <a:avLst/>
+          </a:prstGeom>
+          <a:solidFill>
+            <a:srgbClr val="C8A15A"/>
+          </a:solidFill>
+          <a:ln/>
+        </p:spPr>
+      </p:sp>
+      <p:sp>
+        <p:nvSpPr>
+          <p:cNvPr id="18" name="Text 16"/>
+          <p:cNvSpPr/>
+          <p:nvPr/>
+        </p:nvSpPr>
+        <p:spPr>
+          <a:xfrm>
+            <a:off x="786384" y="4212641"/>
+            <a:ext cx="10707624" cy="627964"/>
+          </a:xfrm>
+          <a:prstGeom prst="rect">
+            <a:avLst/>
+          </a:prstGeom>
+          <a:noFill/>
+          <a:ln/>
+        </p:spPr>
+        <p:txBody>
+          <a:bodyPr wrap="square" rtlCol="0" anchor="ctr">
+            <a:normAutofit/>
+          </a:bodyPr>
+          <a:lstStyle/>
+          <a:p>
+            <a:pPr indent="0" marL="0">
+              <a:lnSpc>
+                <a:spcPct val="102000"/>
+              </a:lnSpc>
+              <a:buNone/>
+            </a:pPr>
+            <a:r>
+              <a:rPr lang="en-US" sz="1250" b="1" dirty="0">
+                <a:solidFill>
+                  <a:srgbClr val="2A2723"/>
+                </a:solidFill>
+                <a:latin typeface="Malgun Gothic" pitchFamily="34" charset="0"/>
+                <a:ea typeface="Malgun Gothic" pitchFamily="34" charset="-122"/>
+                <a:cs typeface="Malgun Gothic" pitchFamily="34" charset="-120"/>
+              </a:rPr>
+              <a:t>A5.</a:t>
+            </a:r>
+            <a:pPr indent="0" marL="0">
+              <a:lnSpc>
+                <a:spcPct val="102000"/>
+              </a:lnSpc>
+              <a:buNone/>
+            </a:pPr>
+            <a:r>
+              <a:rPr lang="en-US" sz="1250" dirty="0">
+                <a:solidFill>
+                  <a:srgbClr val="2A2723"/>
+                </a:solidFill>
+                <a:latin typeface="Malgun Gothic" pitchFamily="34" charset="0"/>
+                <a:ea typeface="Malgun Gothic" pitchFamily="34" charset="-122"/>
+                <a:cs typeface="Malgun Gothic" pitchFamily="34" charset="-120"/>
+              </a:rPr>
+              <a:t> 발이 떴는지 보려 발목 높이를 썼는데, 깊이 앉으면 발목이 올라가 </a:t>
+            </a:r>
+            <a:pPr indent="0" marL="0">
+              <a:lnSpc>
+                <a:spcPct val="102000"/>
+              </a:lnSpc>
+              <a:buNone/>
+            </a:pPr>
+            <a:r>
+              <a:rPr lang="en-US" sz="1250" b="1" dirty="0">
+                <a:solidFill>
+                  <a:srgbClr val="2A2723"/>
+                </a:solidFill>
+                <a:latin typeface="Malgun Gothic" pitchFamily="34" charset="0"/>
+                <a:ea typeface="Malgun Gothic" pitchFamily="34" charset="-122"/>
+                <a:cs typeface="Malgun Gothic" pitchFamily="34" charset="-120"/>
+              </a:rPr>
+              <a:t>스쿼트가 제자리 뛰기로 분류</a:t>
+            </a:r>
+            <a:pPr indent="0" marL="0">
+              <a:lnSpc>
+                <a:spcPct val="102000"/>
+              </a:lnSpc>
+              <a:buNone/>
+            </a:pPr>
+            <a:r>
+              <a:rPr lang="en-US" sz="1250" dirty="0">
+                <a:solidFill>
+                  <a:srgbClr val="2A2723"/>
+                </a:solidFill>
+                <a:latin typeface="Malgun Gothic" pitchFamily="34" charset="0"/>
+                <a:ea typeface="Malgun Gothic" pitchFamily="34" charset="-122"/>
+                <a:cs typeface="Malgun Gothic" pitchFamily="34" charset="-120"/>
+              </a:rPr>
+              <a:t>(값은 계산되나 의도한 걸 안 잼). 판정 항목마다 필요한 축이 달라(깊이·발끝넘음=측면, 좌우벌어짐=정면) </a:t>
+            </a:r>
+            <a:pPr indent="0" marL="0">
+              <a:lnSpc>
+                <a:spcPct val="102000"/>
+              </a:lnSpc>
+              <a:buNone/>
+            </a:pPr>
+            <a:r>
+              <a:rPr lang="en-US" sz="1250" b="1" dirty="0">
+                <a:solidFill>
+                  <a:srgbClr val="2A2723"/>
+                </a:solidFill>
+                <a:latin typeface="Malgun Gothic" pitchFamily="34" charset="0"/>
+                <a:ea typeface="Malgun Gothic" pitchFamily="34" charset="-122"/>
+                <a:cs typeface="Malgun Gothic" pitchFamily="34" charset="-120"/>
+              </a:rPr>
+              <a:t>한 영상으로 다 못 하고, 모델 교체로도 해결 안 됨.</a:t>
+            </a:r>
+            <a:endParaRPr lang="en-US" sz="1250" dirty="0"/>
+          </a:p>
+        </p:txBody>
+      </p:sp>
+    </p:spTree>
+  </p:cSld>
+  <p:clrMapOvr>
+    <a:masterClrMapping/>
+  </p:clrMapOvr>
+</p:sld>
+</file>
+
+<file path=ppt/slides/slide33.xml><?xml version="1.0" encoding="utf-8"?>
+<p:sld xmlns:a="http://schemas.openxmlformats.org/drawingml/2006/main" xmlns:r="http://schemas.openxmlformats.org/officeDocument/2006/relationships" xmlns:p="http://schemas.openxmlformats.org/presentationml/2006/main">
+  <p:cSld name="Slide 33">
+    <p:bg>
+      <p:bgPr>
+        <a:solidFill>
           <a:srgbClr val="2C4D44"/>
         </a:solidFill>
       </p:bgPr>

</xml_diff>